<commit_message>
Bug Beaters : Task done
</commit_message>
<xml_diff>
--- a/docs/pitch-deck.pptx
+++ b/docs/pitch-deck.pptx
@@ -1201,7 +1201,7 @@
                 <a:ea typeface="Calibri" pitchFamily="34" charset="-122"/>
                 <a:cs typeface="Calibri" pitchFamily="34" charset="-120"/>
               </a:rPr>
-              <a:t>Verifi</a:t>
+              <a:t>Veritus AI</a:t>
             </a:r>
             <a:endParaRPr lang="en-US" sz="6000" dirty="0"/>
           </a:p>
@@ -1318,7 +1318,7 @@
                 <a:ea typeface="Calibri" pitchFamily="34" charset="-122"/>
                 <a:cs typeface="Calibri" pitchFamily="34" charset="-120"/>
               </a:rPr>
-              <a:t>Ghunain  ·  Sharjeel  ·  Muheed  ·  Emaan</a:t>
+              <a:t>Team Bug Beaters  ·  Ghunain  ·  Sharjeel  ·  Muheed  ·  Emaan</a:t>
             </a:r>
             <a:endParaRPr lang="en-US" sz="1400" dirty="0"/>
           </a:p>
@@ -1454,7 +1454,7 @@
                 <a:ea typeface="Calibri" pitchFamily="34" charset="-122"/>
                 <a:cs typeface="Calibri" pitchFamily="34" charset="-120"/>
               </a:rPr>
-              <a:t>Verifi</a:t>
+              <a:t>Veritus AI</a:t>
             </a:r>
             <a:endParaRPr lang="en-US" sz="1000" dirty="0"/>
           </a:p>
@@ -1894,7 +1894,7 @@
                 <a:ea typeface="Calibri" pitchFamily="34" charset="-122"/>
                 <a:cs typeface="Calibri" pitchFamily="34" charset="-120"/>
               </a:rPr>
-              <a:t>Verifi</a:t>
+              <a:t>Veritus AI</a:t>
             </a:r>
             <a:endParaRPr lang="en-US" sz="1000" dirty="0"/>
           </a:p>
@@ -2359,7 +2359,7 @@
                 <a:ea typeface="Calibri" pitchFamily="34" charset="-122"/>
                 <a:cs typeface="Calibri" pitchFamily="34" charset="-120"/>
               </a:rPr>
-              <a:t>One engine, four ways to use it</a:t>
+              <a:t>One engine, three ways to use it</a:t>
             </a:r>
             <a:endParaRPr lang="en-US" sz="3000" dirty="0"/>
           </a:p>
@@ -2423,7 +2423,7 @@
                 <a:ea typeface="Calibri" pitchFamily="34" charset="-122"/>
                 <a:cs typeface="Calibri" pitchFamily="34" charset="-120"/>
               </a:rPr>
-              <a:t>Verifi</a:t>
+              <a:t>Veritus AI</a:t>
             </a:r>
             <a:endParaRPr lang="en-US" sz="1000" dirty="0"/>
           </a:p>
@@ -2571,7 +2571,7 @@
                 <a:ea typeface="Calibri" pitchFamily="34" charset="-122"/>
                 <a:cs typeface="Calibri" pitchFamily="34" charset="-120"/>
               </a:rPr>
-              <a:t>Mobile app: Share target, OCR, Urdu voice</a:t>
+              <a:t>Android app: share from WhatsApp, scan a screenshot, Listen</a:t>
             </a:r>
             <a:endParaRPr lang="en-US" sz="1300" dirty="0"/>
           </a:p>
@@ -2592,7 +2592,7 @@
                 <a:ea typeface="Calibri" pitchFamily="34" charset="-122"/>
                 <a:cs typeface="Calibri" pitchFamily="34" charset="-120"/>
               </a:rPr>
-              <a:t>Browser extension: select text, press Check</a:t>
+              <a:t>Chrome extension: select text, right-click, Check</a:t>
             </a:r>
             <a:endParaRPr lang="en-US" sz="1300" dirty="0"/>
           </a:p>
@@ -2613,7 +2613,7 @@
                 <a:ea typeface="Calibri" pitchFamily="34" charset="-122"/>
                 <a:cs typeface="Calibri" pitchFamily="34" charset="-120"/>
               </a:rPr>
-              <a:t>Web app: results page, Rumor Radar, admin and fact-checker views</a:t>
+              <a:t>Web app: claim checker and Rumor Radar</a:t>
             </a:r>
             <a:endParaRPr lang="en-US" sz="1300" dirty="0"/>
           </a:p>
@@ -2634,45 +2634,6 @@
               <a:t>One backend and one API contract for all of them</a:t>
             </a:r>
             <a:endParaRPr lang="en-US" sz="1300" dirty="0"/>
-          </a:p>
-        </p:txBody>
-      </p:sp>
-      <p:sp>
-        <p:nvSpPr>
-          <p:cNvPr id="10" name="Text 8"/>
-          <p:cNvSpPr txBox="1"/>
-          <p:nvPr/>
-        </p:nvSpPr>
-        <p:spPr>
-          <a:xfrm>
-            <a:off x="4937760" y="2468880"/>
-            <a:ext cx="3474720" cy="822960"/>
-          </a:xfrm>
-          <a:prstGeom prst="rect">
-            <a:avLst/>
-          </a:prstGeom>
-          <a:noFill/>
-          <a:ln/>
-        </p:spPr>
-        <p:txBody>
-          <a:bodyPr wrap="square" lIns="0" tIns="0" rIns="0" bIns="0" rtlCol="0" anchor="ctr"/>
-          <a:lstStyle/>
-          <a:p>
-            <a:pPr marL="0" indent="0" algn="ctr">
-              <a:buNone/>
-            </a:pPr>
-            <a:r>
-              <a:rPr lang="en-US" sz="1400" dirty="0">
-                <a:solidFill>
-                  <a:srgbClr val="94A3B8"/>
-                </a:solidFill>
-                <a:latin typeface="Calibri" pitchFamily="34" charset="0"/>
-                <a:ea typeface="Calibri" pitchFamily="34" charset="-122"/>
-                <a:cs typeface="Calibri" pitchFamily="34" charset="-120"/>
-              </a:rPr>
-              <a:t>Replace with a screenshot of the result card (docs/images)</a:t>
-            </a:r>
-            <a:endParaRPr lang="en-US" sz="1400" dirty="0"/>
           </a:p>
         </p:txBody>
       </p:sp>
@@ -2836,7 +2797,7 @@
                 <a:ea typeface="Calibri" pitchFamily="34" charset="-122"/>
                 <a:cs typeface="Calibri" pitchFamily="34" charset="-120"/>
               </a:rPr>
-              <a:t>Verifi</a:t>
+              <a:t>Veritus AI</a:t>
             </a:r>
             <a:endParaRPr lang="en-US" sz="1000" dirty="0"/>
           </a:p>
@@ -3190,7 +3151,7 @@
                 <a:ea typeface="Calibri" pitchFamily="34" charset="-122"/>
                 <a:cs typeface="Calibri" pitchFamily="34" charset="-120"/>
               </a:rPr>
-              <a:t>Reports are anonymous and noisy. A claim shows only after 10 or more different installs report it.</a:t>
+              <a:t>Only fingerprints and salted hashes are kept, in memory. A claim shows only after 10 installs on 3 networks.</a:t>
             </a:r>
             <a:endParaRPr lang="en-US" sz="1300" dirty="0"/>
           </a:p>
@@ -3295,7 +3256,7 @@
                 <a:ea typeface="Calibri" pitchFamily="34" charset="-122"/>
                 <a:cs typeface="Calibri" pitchFamily="34" charset="-120"/>
               </a:rPr>
-              <a:t>Only fingerprints and counts are kept. No sender, no group, no message text.</a:t>
+              <a:t>No accounts, sender, group or message text is kept. Screenshots are read on the phone.</a:t>
             </a:r>
             <a:endParaRPr lang="en-US" sz="1300" dirty="0"/>
           </a:p>
@@ -3431,7 +3392,7 @@
                 <a:ea typeface="Calibri" pitchFamily="34" charset="-122"/>
                 <a:cs typeface="Calibri" pitchFamily="34" charset="-120"/>
               </a:rPr>
-              <a:t>Verifi</a:t>
+              <a:t>Veritus AI</a:t>
             </a:r>
             <a:endParaRPr lang="en-US" sz="1000" dirty="0"/>
           </a:p>
@@ -3536,7 +3497,7 @@
                 <a:ea typeface="Calibri" pitchFamily="34" charset="-122"/>
                 <a:cs typeface="Calibri" pitchFamily="34" charset="-120"/>
               </a:rPr>
-              <a:t>Planned and built protections</a:t>
+              <a:t>Built protections</a:t>
             </a:r>
             <a:endParaRPr lang="en-US" sz="1600" dirty="0"/>
           </a:p>
@@ -3627,6 +3588,27 @@
           </a:p>
           <a:p>
             <a:pPr marL="342900" indent="-342900">
+              <a:buSzPct val="100000"/>
+              <a:buChar char="•"/>
+            </a:pPr>
+            <a:r>
+              <a:rPr lang="en-US" sz="1300" dirty="0">
+                <a:solidFill>
+                  <a:srgbClr val="F8FAFC"/>
+                </a:solidFill>
+                <a:latin typeface="Calibri" pitchFamily="34" charset="0"/>
+                <a:ea typeface="Calibri" pitchFamily="34" charset="-122"/>
+                <a:cs typeface="Calibri" pitchFamily="34" charset="-120"/>
+              </a:rPr>
+              <a:t>Radar threshold: 10 installs on 3 networks</a:t>
+            </a:r>
+            <a:endParaRPr lang="en-US" sz="1300" dirty="0"/>
+          </a:p>
+          <a:p>
+            <a:pPr marL="342900" indent="-342900">
+              <a:spcAft>
+                <a:spcPts val="600"/>
+              </a:spcAft>
               <a:buSzPct val="100000"/>
               <a:buChar char="•"/>
             </a:pPr>
@@ -3705,7 +3687,7 @@
                 <a:ea typeface="Calibri" pitchFamily="34" charset="-122"/>
                 <a:cs typeface="Calibri" pitchFamily="34" charset="-120"/>
               </a:rPr>
-              <a:t>Trust in published answers</a:t>
+              <a:t>Honest by design</a:t>
             </a:r>
             <a:endParaRPr lang="en-US" sz="1600" dirty="0"/>
           </a:p>
@@ -3748,7 +3730,7 @@
                 <a:ea typeface="Calibri" pitchFamily="34" charset="-122"/>
                 <a:cs typeface="Calibri" pitchFamily="34" charset="-120"/>
               </a:rPr>
-              <a:t>Fact-checker responses need an API key and are signed</a:t>
+              <a:t>A confidence range plus sources, never a bare TRUE or FALSE</a:t>
             </a:r>
             <a:endParaRPr lang="en-US" sz="1300" dirty="0"/>
           </a:p>
@@ -3769,7 +3751,7 @@
                 <a:ea typeface="Calibri" pitchFamily="34" charset="-122"/>
                 <a:cs typeface="Calibri" pitchFamily="34" charset="-120"/>
               </a:rPr>
-              <a:t>Radar threshold stops a few accounts from faking a trend</a:t>
+              <a:t>Opinion, satire and faith are refused, with a reason</a:t>
             </a:r>
             <a:endParaRPr lang="en-US" sz="1300" dirty="0"/>
           </a:p>
@@ -3923,7 +3905,7 @@
                 <a:ea typeface="Calibri" pitchFamily="34" charset="-122"/>
                 <a:cs typeface="Calibri" pitchFamily="34" charset="-120"/>
               </a:rPr>
-              <a:t>Verifi</a:t>
+              <a:t>Veritus AI</a:t>
             </a:r>
             <a:endParaRPr lang="en-US" sz="1000" dirty="0"/>
           </a:p>
@@ -4071,7 +4053,7 @@
                 <a:ea typeface="Calibri" pitchFamily="34" charset="-122"/>
                 <a:cs typeface="Calibri" pitchFamily="34" charset="-120"/>
               </a:rPr>
-              <a:t>Private lookup and instant cached answers</a:t>
+              <a:t>Persistent storage for cache and radar</a:t>
             </a:r>
             <a:endParaRPr lang="en-US" sz="1300" dirty="0"/>
           </a:p>
@@ -4092,7 +4074,7 @@
                 <a:ea typeface="Calibri" pitchFamily="34" charset="-122"/>
                 <a:cs typeface="Calibri" pitchFamily="34" charset="-120"/>
               </a:rPr>
-              <a:t>Live Rumor Radar for trending claims</a:t>
+              <a:t>Partner fact-checkers publish official responses</a:t>
             </a:r>
             <a:endParaRPr lang="en-US" sz="1300" dirty="0"/>
           </a:p>
@@ -4113,7 +4095,7 @@
                 <a:ea typeface="Calibri" pitchFamily="34" charset="-122"/>
                 <a:cs typeface="Calibri" pitchFamily="34" charset="-120"/>
               </a:rPr>
-              <a:t>Partner fact-checkers publish official responses</a:t>
+              <a:t>Urdu script reading and more voice coverage</a:t>
             </a:r>
             <a:endParaRPr lang="en-US" sz="1300" dirty="0"/>
           </a:p>
@@ -4131,7 +4113,7 @@
                 <a:ea typeface="Calibri" pitchFamily="34" charset="-122"/>
                 <a:cs typeface="Calibri" pitchFamily="34" charset="-120"/>
               </a:rPr>
-              <a:t>More Urdu voice and Roman Urdu coverage</a:t>
+              <a:t>Play Store and Chrome Web Store release</a:t>
             </a:r>
             <a:endParaRPr lang="en-US" sz="1300" dirty="0"/>
           </a:p>
@@ -4240,7 +4222,7 @@
                 <a:ea typeface="Calibri" pitchFamily="34" charset="-122"/>
                 <a:cs typeface="Calibri" pitchFamily="34" charset="-120"/>
               </a:rPr>
-              <a:t>Ghunain: agents, mobile app, API contract</a:t>
+              <a:t>Ghunain: research agents, Android app, API contract</a:t>
             </a:r>
             <a:endParaRPr lang="en-US" sz="1300" dirty="0"/>
           </a:p>
@@ -4261,7 +4243,7 @@
                 <a:ea typeface="Calibri" pitchFamily="34" charset="-122"/>
                 <a:cs typeface="Calibri" pitchFamily="34" charset="-120"/>
               </a:rPr>
-              <a:t>Sharjeel: backend, security, privacy</a:t>
+              <a:t>Sharjeel: API, security, privacy</a:t>
             </a:r>
             <a:endParaRPr lang="en-US" sz="1300" dirty="0"/>
           </a:p>
@@ -4282,7 +4264,7 @@
                 <a:ea typeface="Calibri" pitchFamily="34" charset="-122"/>
                 <a:cs typeface="Calibri" pitchFamily="34" charset="-120"/>
               </a:rPr>
-              <a:t>Muheed: browser extension</a:t>
+              <a:t>Muheed: Chrome extension</a:t>
             </a:r>
             <a:endParaRPr lang="en-US" sz="1300" dirty="0"/>
           </a:p>
@@ -4300,7 +4282,7 @@
                 <a:ea typeface="Calibri" pitchFamily="34" charset="-122"/>
                 <a:cs typeface="Calibri" pitchFamily="34" charset="-120"/>
               </a:rPr>
-              <a:t>Emaan: web app, docs, pitch</a:t>
+              <a:t>Emaan: web app and docs</a:t>
             </a:r>
             <a:endParaRPr lang="en-US" sz="1300" dirty="0"/>
           </a:p>

</xml_diff>

<commit_message>
Bug Beaters: Last commit
</commit_message>
<xml_diff>
--- a/docs/pitch-deck.pptx
+++ b/docs/pitch-deck.pptx
@@ -1420,6 +1420,13 @@
             <a:prstDash val="solid"/>
           </a:ln>
         </p:spPr>
+        <p:txBody>
+          <a:bodyPr/>
+          <a:lstStyle/>
+          <a:p>
+            <a:endParaRPr lang="en-PK"/>
+          </a:p>
+        </p:txBody>
       </p:sp>
       <p:sp>
         <p:nvSpPr>
@@ -1603,6 +1610,13 @@
             <a:prstDash val="solid"/>
           </a:ln>
         </p:spPr>
+        <p:txBody>
+          <a:bodyPr/>
+          <a:lstStyle/>
+          <a:p>
+            <a:endParaRPr lang="en-PK"/>
+          </a:p>
+        </p:txBody>
       </p:sp>
       <p:sp>
         <p:nvSpPr>
@@ -1860,6 +1874,13 @@
             <a:prstDash val="solid"/>
           </a:ln>
         </p:spPr>
+        <p:txBody>
+          <a:bodyPr/>
+          <a:lstStyle/>
+          <a:p>
+            <a:endParaRPr lang="en-PK"/>
+          </a:p>
+        </p:txBody>
       </p:sp>
       <p:sp>
         <p:nvSpPr>
@@ -1965,6 +1986,13 @@
             <a:prstDash val="solid"/>
           </a:ln>
         </p:spPr>
+        <p:txBody>
+          <a:bodyPr/>
+          <a:lstStyle/>
+          <a:p>
+            <a:endParaRPr lang="en-PK"/>
+          </a:p>
+        </p:txBody>
       </p:sp>
       <p:sp>
         <p:nvSpPr>
@@ -2070,6 +2098,13 @@
             <a:prstDash val="solid"/>
           </a:ln>
         </p:spPr>
+        <p:txBody>
+          <a:bodyPr/>
+          <a:lstStyle/>
+          <a:p>
+            <a:endParaRPr lang="en-PK"/>
+          </a:p>
+        </p:txBody>
       </p:sp>
       <p:sp>
         <p:nvSpPr>
@@ -2175,6 +2210,13 @@
             <a:prstDash val="solid"/>
           </a:ln>
         </p:spPr>
+        <p:txBody>
+          <a:bodyPr/>
+          <a:lstStyle/>
+          <a:p>
+            <a:endParaRPr lang="en-PK"/>
+          </a:p>
+        </p:txBody>
       </p:sp>
       <p:sp>
         <p:nvSpPr>
@@ -2389,6 +2431,13 @@
             <a:prstDash val="solid"/>
           </a:ln>
         </p:spPr>
+        <p:txBody>
+          <a:bodyPr/>
+          <a:lstStyle/>
+          <a:p>
+            <a:endParaRPr lang="en-PK"/>
+          </a:p>
+        </p:txBody>
       </p:sp>
       <p:sp>
         <p:nvSpPr>
@@ -2476,8 +2525,8 @@
         </p:nvSpPr>
         <p:spPr>
           <a:xfrm>
-            <a:off x="548640" y="1371600"/>
-            <a:ext cx="3931920" cy="3017520"/>
+            <a:off x="133644" y="1721512"/>
+            <a:ext cx="1990578" cy="2987648"/>
           </a:xfrm>
           <a:prstGeom prst="roundRect">
             <a:avLst>
@@ -2494,6 +2543,13 @@
             <a:prstDash val="solid"/>
           </a:ln>
         </p:spPr>
+        <p:txBody>
+          <a:bodyPr/>
+          <a:lstStyle/>
+          <a:p>
+            <a:endParaRPr lang="en-PK"/>
+          </a:p>
+        </p:txBody>
       </p:sp>
       <p:sp>
         <p:nvSpPr>
@@ -2503,7 +2559,7 @@
         </p:nvSpPr>
         <p:spPr>
           <a:xfrm>
-            <a:off x="731520" y="1508760"/>
+            <a:off x="341142" y="1275033"/>
             <a:ext cx="3566160" cy="365760"/>
           </a:xfrm>
           <a:prstGeom prst="rect">
@@ -2542,8 +2598,8 @@
         </p:nvSpPr>
         <p:spPr>
           <a:xfrm>
-            <a:off x="731520" y="1920240"/>
-            <a:ext cx="3566160" cy="2331720"/>
+            <a:off x="210127" y="1771927"/>
+            <a:ext cx="1766160" cy="1444752"/>
           </a:xfrm>
           <a:prstGeom prst="rect">
             <a:avLst/>
@@ -2639,10 +2695,10 @@
       </p:sp>
       <p:pic>
         <p:nvPicPr>
-          <p:cNvPr id="14" name="Picture 13">
+          <p:cNvPr id="12" name="Picture 11">
             <a:extLst>
               <a:ext uri="{FF2B5EF4-FFF2-40B4-BE49-F238E27FC236}">
-                <a16:creationId xmlns:a16="http://schemas.microsoft.com/office/drawing/2014/main" id="{7C496194-E206-BC6B-87F6-A1A6D288C47D}"/>
+                <a16:creationId xmlns:a16="http://schemas.microsoft.com/office/drawing/2014/main" id="{B82BD391-F3D2-1985-1B83-56103B986C09}"/>
               </a:ext>
             </a:extLst>
           </p:cNvPr>
@@ -2659,8 +2715,8 @@
         </p:blipFill>
         <p:spPr>
           <a:xfrm>
-            <a:off x="4770111" y="933062"/>
-            <a:ext cx="4008129" cy="4050418"/>
+            <a:off x="2514600" y="1194314"/>
+            <a:ext cx="6419273" cy="3421966"/>
           </a:xfrm>
           <a:prstGeom prst="rect">
             <a:avLst/>
@@ -2763,6 +2819,13 @@
             <a:prstDash val="solid"/>
           </a:ln>
         </p:spPr>
+        <p:txBody>
+          <a:bodyPr/>
+          <a:lstStyle/>
+          <a:p>
+            <a:endParaRPr lang="en-PK"/>
+          </a:p>
+        </p:txBody>
       </p:sp>
       <p:sp>
         <p:nvSpPr>
@@ -2868,6 +2931,13 @@
             <a:prstDash val="solid"/>
           </a:ln>
         </p:spPr>
+        <p:txBody>
+          <a:bodyPr/>
+          <a:lstStyle/>
+          <a:p>
+            <a:endParaRPr lang="en-PK"/>
+          </a:p>
+        </p:txBody>
       </p:sp>
       <p:sp>
         <p:nvSpPr>
@@ -2973,6 +3043,13 @@
             <a:prstDash val="solid"/>
           </a:ln>
         </p:spPr>
+        <p:txBody>
+          <a:bodyPr/>
+          <a:lstStyle/>
+          <a:p>
+            <a:endParaRPr lang="en-PK"/>
+          </a:p>
+        </p:txBody>
       </p:sp>
       <p:sp>
         <p:nvSpPr>
@@ -3078,6 +3155,13 @@
             <a:prstDash val="solid"/>
           </a:ln>
         </p:spPr>
+        <p:txBody>
+          <a:bodyPr/>
+          <a:lstStyle/>
+          <a:p>
+            <a:endParaRPr lang="en-PK"/>
+          </a:p>
+        </p:txBody>
       </p:sp>
       <p:sp>
         <p:nvSpPr>
@@ -3183,6 +3267,13 @@
             <a:prstDash val="solid"/>
           </a:ln>
         </p:spPr>
+        <p:txBody>
+          <a:bodyPr/>
+          <a:lstStyle/>
+          <a:p>
+            <a:endParaRPr lang="en-PK"/>
+          </a:p>
+        </p:txBody>
       </p:sp>
       <p:sp>
         <p:nvSpPr>
@@ -3358,6 +3449,13 @@
             <a:prstDash val="solid"/>
           </a:ln>
         </p:spPr>
+        <p:txBody>
+          <a:bodyPr/>
+          <a:lstStyle/>
+          <a:p>
+            <a:endParaRPr lang="en-PK"/>
+          </a:p>
+        </p:txBody>
       </p:sp>
       <p:sp>
         <p:nvSpPr>
@@ -3463,6 +3561,13 @@
             <a:prstDash val="solid"/>
           </a:ln>
         </p:spPr>
+        <p:txBody>
+          <a:bodyPr/>
+          <a:lstStyle/>
+          <a:p>
+            <a:endParaRPr lang="en-PK"/>
+          </a:p>
+        </p:txBody>
       </p:sp>
       <p:sp>
         <p:nvSpPr>
@@ -3653,6 +3758,13 @@
             <a:prstDash val="solid"/>
           </a:ln>
         </p:spPr>
+        <p:txBody>
+          <a:bodyPr/>
+          <a:lstStyle/>
+          <a:p>
+            <a:endParaRPr lang="en-PK"/>
+          </a:p>
+        </p:txBody>
       </p:sp>
       <p:sp>
         <p:nvSpPr>
@@ -3871,6 +3983,13 @@
             <a:prstDash val="solid"/>
           </a:ln>
         </p:spPr>
+        <p:txBody>
+          <a:bodyPr/>
+          <a:lstStyle/>
+          <a:p>
+            <a:endParaRPr lang="en-PK"/>
+          </a:p>
+        </p:txBody>
       </p:sp>
       <p:sp>
         <p:nvSpPr>
@@ -3976,6 +4095,13 @@
             <a:prstDash val="solid"/>
           </a:ln>
         </p:spPr>
+        <p:txBody>
+          <a:bodyPr/>
+          <a:lstStyle/>
+          <a:p>
+            <a:endParaRPr lang="en-PK"/>
+          </a:p>
+        </p:txBody>
       </p:sp>
       <p:sp>
         <p:nvSpPr>
@@ -4145,6 +4271,13 @@
             <a:prstDash val="solid"/>
           </a:ln>
         </p:spPr>
+        <p:txBody>
+          <a:bodyPr/>
+          <a:lstStyle/>
+          <a:p>
+            <a:endParaRPr lang="en-PK"/>
+          </a:p>
+        </p:txBody>
       </p:sp>
       <p:sp>
         <p:nvSpPr>

</xml_diff>